<commit_message>
update presentation file for Zero Context Shop Honest AI Builder Cup review
</commit_message>
<xml_diff>
--- a/Zero Context - Shop Honest - AI Builder Cup - Reviewed.pptx
+++ b/Zero Context - Shop Honest - AI Builder Cup - Reviewed.pptx
@@ -1509,7 +1509,7 @@
           <a:lstStyle/>
           <a:p>
             <a:r>
-              <a:t>The first three screenshots show the prototype's demo-store verdict, bill and captured evidence. The Tata 1mg panel renders an existing production audit (aud_143d37231570, 16 October 2026) in the current local frontend with the corrected NEEDS A HUMAN label. It reached product, variant and cart and stopped at checkout sign-in. Two observations await human review. The displayed cart price is not a completed payment or a legal finding. The production site still needs the frontend verdict deployment at the time of this capture.</a:t>
+              <a:t>The first three screenshots show the prototype's demo-store verdict, bill and captured evidence. The Tata 1mg panel renders an existing production audit (aud_143d37231570, 16 October 2026) in the deployed frontend with the corrected NEEDS A HUMAN label. It reached product, variant and cart and stopped at checkout sign-in. Two observations await human review. The displayed cart price is not a completed payment or a legal finding. Captured from https://shop-honest-ai.web.app/audit/aud_143d37231570 after the frontend deployment on 16 October 2026. The live report shows NEEDS A HUMAN and 3 of 5 steps checked.</a:t>
             </a:r>
           </a:p>
         </p:txBody>
@@ -11349,7 +11349,7 @@
                 </a:solidFill>
                 <a:latin typeface="Google Sans Flex"/>
               </a:rPr>
-              <a:t>1mg: 2 claims for review · local UI</a:t>
+              <a:t>1mg: 2 claims for review · live site</a:t>
             </a:r>
           </a:p>
         </p:txBody>

</xml_diff>